<commit_message>
Replace remaining black panels with steel-dark, obscure CIDC Chinese UI text
- Introduce a distinct steel-graphite background tone (#383D42) for
  full dark slide/panel backgrounds (section dividers, geography
  slide, About slide's header band, contacts panel) so they read as
  a premium graphite rather than flat black, in both HTML and PPTX.
  Text-color usages of the near-black ink color are untouched.
- Re-crop and heavily gaussian-blur the CIDC platform dashboard
  screenshot (case slide under Международный опыт) to obscure its
  Chinese title bar, navigation, and alert panel text while keeping
  the dashboard's visual shape as case evidence. Checked the other
  photos on the same run of slides (client logos, equipment closeups,
  Brazil/Chile site photos) — no other readable Chinese text found.
</commit_message>
<xml_diff>
--- a/presentations/algoritm/algoritm-predictive-maintenance-Swiss-full.pptx
+++ b/presentations/algoritm/algoritm-predictive-maintenance-Swiss-full.pptx
@@ -3609,7 +3609,7 @@
             <a:avLst/>
           </a:prstGeom>
           <a:solidFill>
-            <a:srgbClr val="141212"/>
+            <a:srgbClr val="383D42"/>
           </a:solidFill>
           <a:ln>
             <a:noFill/>
@@ -3658,7 +3658,7 @@
                 <a:srgbClr val="93402B"/>
               </a:gs>
               <a:gs pos="100000">
-                <a:srgbClr val="141212"/>
+                <a:srgbClr val="383D42"/>
               </a:gs>
             </a:gsLst>
             <a:lin scaled="0" ang="13500000"/>
@@ -10263,7 +10263,7 @@
             <a:avLst/>
           </a:prstGeom>
           <a:solidFill>
-            <a:srgbClr val="141212"/>
+            <a:srgbClr val="383D42"/>
           </a:solidFill>
           <a:ln>
             <a:noFill/>
@@ -10312,7 +10312,7 @@
                 <a:srgbClr val="93402B"/>
               </a:gs>
               <a:gs pos="100000">
-                <a:srgbClr val="141212"/>
+                <a:srgbClr val="383D42"/>
               </a:gs>
             </a:gsLst>
             <a:lin scaled="0" ang="13500000"/>
@@ -14677,7 +14677,7 @@
             <a:avLst/>
           </a:prstGeom>
           <a:solidFill>
-            <a:srgbClr val="141212"/>
+            <a:srgbClr val="383D42"/>
           </a:solidFill>
           <a:ln>
             <a:noFill/>
@@ -14726,7 +14726,7 @@
                 <a:srgbClr val="93402B"/>
               </a:gs>
               <a:gs pos="100000">
-                <a:srgbClr val="141212"/>
+                <a:srgbClr val="383D42"/>
               </a:gs>
             </a:gsLst>
             <a:lin scaled="0" ang="13500000"/>
@@ -17177,7 +17177,7 @@
             <a:avLst/>
           </a:prstGeom>
           <a:solidFill>
-            <a:srgbClr val="141212"/>
+            <a:srgbClr val="383D42"/>
           </a:solidFill>
           <a:ln>
             <a:noFill/>
@@ -17226,7 +17226,7 @@
                 <a:srgbClr val="93402B"/>
               </a:gs>
               <a:gs pos="100000">
-                <a:srgbClr val="141212"/>
+                <a:srgbClr val="383D42"/>
               </a:gs>
             </a:gsLst>
             <a:lin scaled="0" ang="13500000"/>
@@ -17426,7 +17426,7 @@
             <a:avLst/>
           </a:prstGeom>
           <a:solidFill>
-            <a:srgbClr val="141212"/>
+            <a:srgbClr val="383D42"/>
           </a:solidFill>
           <a:ln>
             <a:noFill/>
@@ -20791,8 +20791,8 @@
         </p:blipFill>
         <p:spPr>
           <a:xfrm>
-            <a:off x="2258568" y="2443172"/>
-            <a:ext cx="7644384" cy="3014071"/>
+            <a:off x="2258568" y="3309991"/>
+            <a:ext cx="7644384" cy="1280434"/>
           </a:xfrm>
           <a:prstGeom prst="rect">
             <a:avLst/>
@@ -20807,7 +20807,7 @@
         </p:nvSpPr>
         <p:spPr>
           <a:xfrm>
-            <a:off x="2258568" y="5182923"/>
+            <a:off x="2258568" y="4316105"/>
             <a:ext cx="7644384" cy="274320"/>
           </a:xfrm>
           <a:prstGeom prst="rect">
@@ -21637,7 +21637,7 @@
             <a:avLst/>
           </a:prstGeom>
           <a:solidFill>
-            <a:srgbClr val="141212"/>
+            <a:srgbClr val="383D42"/>
           </a:solidFill>
           <a:ln>
             <a:noFill/>
@@ -25251,7 +25251,7 @@
             <a:avLst/>
           </a:prstGeom>
           <a:solidFill>
-            <a:srgbClr val="141212"/>
+            <a:srgbClr val="383D42"/>
           </a:solidFill>
           <a:ln>
             <a:noFill/>

</xml_diff>